<commit_message>
update PPT to CatBoost data + regenerate charts
</commit_message>
<xml_diff>
--- a/code/deliverables/讲解版.pptx
+++ b/code/deliverables/讲解版.pptx
@@ -3259,7 +3259,7 @@
                   <a:srgbClr val="BFD3E6"/>
                 </a:solidFill>
               </a:rPr>
-              <a:t>基于 LightGBM 的方向分类与单边套利策略</a:t>
+              <a:t>基于 CatBoost 的方向分类与单边套利策略</a:t>
             </a:r>
           </a:p>
         </p:txBody>
@@ -3313,7 +3313,7 @@
                   <a:srgbClr val="C9A227"/>
                 </a:solidFill>
               </a:rPr>
-              <a:t>62.6%</a:t>
+              <a:t>63.9%</a:t>
             </a:r>
           </a:p>
           <a:p>
@@ -3378,7 +3378,7 @@
                   <a:srgbClr val="C9A227"/>
                 </a:solidFill>
               </a:rPr>
-              <a:t>67.8%</a:t>
+              <a:t>68.8%</a:t>
             </a:r>
           </a:p>
           <a:p>
@@ -3443,7 +3443,7 @@
                   <a:srgbClr val="C9A227"/>
                 </a:solidFill>
               </a:rPr>
-              <a:t>+1744</a:t>
+              <a:t>+2243</a:t>
             </a:r>
           </a:p>
           <a:p>
@@ -3799,7 +3799,7 @@
                   <a:srgbClr val="1F4E79"/>
                 </a:solidFill>
               </a:rPr>
-              <a:t>•  ① 方向准确率（核心业务指标）：整体 62.6%；交易时段命中率 67.8%（只看实际下单样本，更贴业务）</a:t>
+              <a:t>•  ① 方向准确率（核心业务指标）：整体 63.9%（val 65.3%）；交易时段命中率 68.8%（val 71.3%）（只看实际下单样本，更贴业务）</a:t>
             </a:r>
           </a:p>
           <a:p>
@@ -3835,7 +3835,7 @@
                   <a:srgbClr val="333333"/>
                 </a:solidFill>
               </a:rPr>
-              <a:t>•  ③ 决策质量：卖 31% / 观望 69%；每类决策平均收益；hold 是否避开了大额亏损</a:t>
+              <a:t>•  ③ 决策质量：卖 33% / 观望 67%（单边、无买）；每类决策平均收益；hold 是否避开了大额亏损</a:t>
             </a:r>
           </a:p>
           <a:p>
@@ -3871,7 +3871,7 @@
                   <a:srgbClr val="1F4E79"/>
                 </a:solidFill>
               </a:rPr>
-              <a:t>•  ⑤ 稳健性：val（2026 H1）+5074 与 test（2026 H2）+1744 双时段均正收益</a:t>
+              <a:t>•  ⑤ 稳健性：val（2026 H1）+6884 与 test（2026 H2）+2243 双时段均正收益</a:t>
             </a:r>
           </a:p>
         </p:txBody>
@@ -4831,7 +4831,7 @@
                   <a:srgbClr val="1F4E79"/>
                 </a:solidFill>
               </a:rPr>
-              <a:t>•  套利利润偏薄：val +5074 / test +1744，日均约 27–60 —— 价差本身难预测，62.6% 方向准确率带来的收益空间有限</a:t>
+              <a:t>•  套利利润偏薄：val +6884 / test +2243（test 日均约 +35）—— 价差本身难预测，63.9% 方向准确率带来的收益空间有限</a:t>
             </a:r>
           </a:p>
           <a:p>
@@ -4867,7 +4867,7 @@
                   <a:srgbClr val="333333"/>
                 </a:solidFill>
               </a:rPr>
-              <a:t>•  交易集中在 SNLNDRO：CONTROLX 在单边规则下几乎不交易</a:t>
+              <a:t>•  交易完全集中在 SNLNDRO：CONTROLX 在单边规则下 test 0 笔交易</a:t>
             </a:r>
           </a:p>
           <a:p>
@@ -5129,7 +5129,7 @@
                   <a:srgbClr val="1F4E79"/>
                 </a:solidFill>
               </a:rPr>
-              <a:t>•  方向准确率 62.6%（交易时段 67.8%），模拟套利 val +5074 / test +1744，收益为正、风险可控</a:t>
+              <a:t>•  方向准确率 63.9%（交易时段 68.8%），模拟套利 val +6884 / test +2243，收益为正、风险可控</a:t>
             </a:r>
           </a:p>
           <a:p>
@@ -7151,7 +7151,7 @@
                   <a:srgbClr val="1F4E79"/>
                 </a:solidFill>
               </a:rPr>
-              <a:t>•  决策核心：LightGBM 方向分类器，目标 y = (价差 &gt; 0)，直接输出 P(价差 &gt; 0)</a:t>
+              <a:t>•  决策核心：CatBoost 方向分类器，目标 y = (价差 &gt; 0)，直接输出 P(价差 &gt; 0)</a:t>
             </a:r>
           </a:p>
           <a:p>
@@ -7169,7 +7169,7 @@
                   <a:srgbClr val="333333"/>
                 </a:solidFill>
               </a:rPr>
-              <a:t>•  训练用 val 早停，缺省特征由 LightGBM 原生处理 NaN</a:t>
+              <a:t>•  训练用 val 早停，缺省特征由 CatBoost 原生处理 NaN</a:t>
             </a:r>
           </a:p>
           <a:p>
@@ -7205,7 +7205,7 @@
                   <a:srgbClr val="1F4E79"/>
                 </a:solidFill>
               </a:rPr>
-              <a:t>•  实测方向信号不对称：卖方向命中 71% vs 买方向 58% —— 负价差方向错单是亏损主因</a:t>
+              <a:t>•  实测 CatBoost 优于 LightGBM：test 套利收益 +30%（+1744 → +2243）</a:t>
             </a:r>
           </a:p>
           <a:p>
@@ -7223,7 +7223,7 @@
                   <a:srgbClr val="1F4E79"/>
                 </a:solidFill>
               </a:rPr>
-              <a:t>•  单边决策规则（经回测校准）：</a:t>
+              <a:t>•  单边决策（无买）：sell 约 33% / hold 约 67% —— 规则经回测校准：</a:t>
             </a:r>
           </a:p>
         </p:txBody>
@@ -7519,7 +7519,7 @@
         </p:nvGraphicFramePr>
         <p:xfrm>
           <a:off x="502920" y="1298448"/>
-          <a:ext cx="11155677" cy="3236976"/>
+          <a:ext cx="11155677" cy="2286000"/>
         </p:xfrm>
         <a:graphic>
           <a:graphicData uri="http://schemas.openxmlformats.org/drawingml/2006/table">
@@ -7721,7 +7721,7 @@
                 </a:tc>
               </a:tr>
               <a:tr h="475488">
-                <a:tc rowSpan="2">
+                <a:tc>
                   <a:txBody>
                     <a:bodyPr wrap="square"/>
                     <a:lstStyle/>
@@ -7735,14 +7735,6 @@
                         <a:rPr sz="1200" b="0">
                           <a:solidFill>
                             <a:srgbClr val="333333"/>
-                          </a:solidFill>
-                        </a:rPr>
-                        <a:t>SNLNDRO</a:t>
-                      </a:r>
-                      <a:r>
-                        <a:rPr sz="1300" b="1">
-                          <a:solidFill>
-                            <a:srgbClr val="1F4E79"/>
                           </a:solidFill>
                         </a:rPr>
                         <a:t>SNLNDRO</a:t>
@@ -7771,7 +7763,7 @@
                             <a:srgbClr val="333333"/>
                           </a:solidFill>
                         </a:rPr>
-                        <a:t>val</a:t>
+                        <a:t>test</a:t>
                       </a:r>
                     </a:p>
                   </a:txBody>
@@ -7797,7 +7789,7 @@
                             <a:srgbClr val="333333"/>
                           </a:solidFill>
                         </a:rPr>
-                        <a:t>1931 (53%)</a:t>
+                        <a:t>1018 (65%)</a:t>
                       </a:r>
                     </a:p>
                   </a:txBody>
@@ -7823,7 +7815,7 @@
                             <a:srgbClr val="333333"/>
                           </a:solidFill>
                         </a:rPr>
-                        <a:t>69.9%</a:t>
+                        <a:t>68.8%</a:t>
                       </a:r>
                     </a:p>
                   </a:txBody>
@@ -7849,7 +7841,7 @@
                             <a:srgbClr val="333333"/>
                           </a:solidFill>
                         </a:rPr>
-                        <a:t>+5483</a:t>
+                        <a:t>+2243</a:t>
                       </a:r>
                     </a:p>
                   </a:txBody>
@@ -7875,7 +7867,7 @@
                             <a:srgbClr val="333333"/>
                           </a:solidFill>
                         </a:rPr>
-                        <a:t>66.6%</a:t>
+                        <a:t>62.6%</a:t>
                       </a:r>
                     </a:p>
                   </a:txBody>
@@ -7901,7 +7893,7 @@
                             <a:srgbClr val="333333"/>
                           </a:solidFill>
                         </a:rPr>
-                        <a:t>9.9</a:t>
+                        <a:t>7.8</a:t>
                       </a:r>
                     </a:p>
                   </a:txBody>
@@ -7913,7 +7905,7 @@
                 </a:tc>
               </a:tr>
               <a:tr h="475488">
-                <a:tc vMerge="1">
+                <a:tc>
                   <a:txBody>
                     <a:bodyPr wrap="square"/>
                     <a:lstStyle/>
@@ -7929,7 +7921,7 @@
                             <a:srgbClr val="333333"/>
                           </a:solidFill>
                         </a:rPr>
-                        <a:t/>
+                        <a:t>CONTROLX</a:t>
                       </a:r>
                     </a:p>
                   </a:txBody>
@@ -7981,7 +7973,7 @@
                             <a:srgbClr val="333333"/>
                           </a:solidFill>
                         </a:rPr>
-                        <a:t>958 (61%)</a:t>
+                        <a:t>0 (0%)</a:t>
                       </a:r>
                     </a:p>
                   </a:txBody>
@@ -8007,7 +7999,7 @@
                             <a:srgbClr val="333333"/>
                           </a:solidFill>
                         </a:rPr>
-                        <a:t>68.0%</a:t>
+                        <a:t>—</a:t>
                       </a:r>
                     </a:p>
                   </a:txBody>
@@ -8033,383 +8025,7 @@
                             <a:srgbClr val="333333"/>
                           </a:solidFill>
                         </a:rPr>
-                        <a:t>+1808</a:t>
-                      </a:r>
-                    </a:p>
-                  </a:txBody>
-                  <a:tcPr marL="54864" marR="54864" marT="18288" marB="18288" anchor="ctr">
-                    <a:solidFill>
-                      <a:srgbClr val="F2F2F2"/>
-                    </a:solidFill>
-                  </a:tcPr>
-                </a:tc>
-                <a:tc>
-                  <a:txBody>
-                    <a:bodyPr wrap="square"/>
-                    <a:lstStyle/>
-                    <a:p>
-                      <a:pPr algn="ctr">
-                        <a:lnSpc>
-                          <a:spcPct val="100000"/>
-                        </a:lnSpc>
-                      </a:pPr>
-                      <a:r>
-                        <a:rPr sz="1200" b="0">
-                          <a:solidFill>
-                            <a:srgbClr val="333333"/>
-                          </a:solidFill>
-                        </a:rPr>
-                        <a:t>62.6%</a:t>
-                      </a:r>
-                    </a:p>
-                  </a:txBody>
-                  <a:tcPr marL="54864" marR="54864" marT="18288" marB="18288" anchor="ctr">
-                    <a:solidFill>
-                      <a:srgbClr val="F2F2F2"/>
-                    </a:solidFill>
-                  </a:tcPr>
-                </a:tc>
-                <a:tc>
-                  <a:txBody>
-                    <a:bodyPr wrap="square"/>
-                    <a:lstStyle/>
-                    <a:p>
-                      <a:pPr algn="ctr">
-                        <a:lnSpc>
-                          <a:spcPct val="100000"/>
-                        </a:lnSpc>
-                      </a:pPr>
-                      <a:r>
-                        <a:rPr sz="1200" b="0">
-                          <a:solidFill>
-                            <a:srgbClr val="333333"/>
-                          </a:solidFill>
-                        </a:rPr>
-                        <a:t>7.8</a:t>
-                      </a:r>
-                    </a:p>
-                  </a:txBody>
-                  <a:tcPr marL="54864" marR="54864" marT="18288" marB="18288" anchor="ctr">
-                    <a:solidFill>
-                      <a:srgbClr val="F2F2F2"/>
-                    </a:solidFill>
-                  </a:tcPr>
-                </a:tc>
-              </a:tr>
-              <a:tr h="475488">
-                <a:tc rowSpan="2">
-                  <a:txBody>
-                    <a:bodyPr wrap="square"/>
-                    <a:lstStyle/>
-                    <a:p>
-                      <a:pPr algn="ctr">
-                        <a:lnSpc>
-                          <a:spcPct val="100000"/>
-                        </a:lnSpc>
-                      </a:pPr>
-                      <a:r>
-                        <a:rPr sz="1200" b="0">
-                          <a:solidFill>
-                            <a:srgbClr val="333333"/>
-                          </a:solidFill>
-                        </a:rPr>
-                        <a:t>CONTROLX</a:t>
-                      </a:r>
-                      <a:r>
-                        <a:rPr sz="1300" b="1">
-                          <a:solidFill>
-                            <a:srgbClr val="1F4E79"/>
-                          </a:solidFill>
-                        </a:rPr>
-                        <a:t>CONTROLX</a:t>
-                      </a:r>
-                    </a:p>
-                  </a:txBody>
-                  <a:tcPr marL="54864" marR="54864" marT="18288" marB="18288" anchor="ctr">
-                    <a:solidFill>
-                      <a:srgbClr val="FFFFFF"/>
-                    </a:solidFill>
-                  </a:tcPr>
-                </a:tc>
-                <a:tc>
-                  <a:txBody>
-                    <a:bodyPr wrap="square"/>
-                    <a:lstStyle/>
-                    <a:p>
-                      <a:pPr algn="ctr">
-                        <a:lnSpc>
-                          <a:spcPct val="100000"/>
-                        </a:lnSpc>
-                      </a:pPr>
-                      <a:r>
-                        <a:rPr sz="1200" b="0">
-                          <a:solidFill>
-                            <a:srgbClr val="333333"/>
-                          </a:solidFill>
-                        </a:rPr>
-                        <a:t>val</a:t>
-                      </a:r>
-                    </a:p>
-                  </a:txBody>
-                  <a:tcPr marL="54864" marR="54864" marT="18288" marB="18288" anchor="ctr">
-                    <a:solidFill>
-                      <a:srgbClr val="FFFFFF"/>
-                    </a:solidFill>
-                  </a:tcPr>
-                </a:tc>
-                <a:tc>
-                  <a:txBody>
-                    <a:bodyPr wrap="square"/>
-                    <a:lstStyle/>
-                    <a:p>
-                      <a:pPr algn="ctr">
-                        <a:lnSpc>
-                          <a:spcPct val="100000"/>
-                        </a:lnSpc>
-                      </a:pPr>
-                      <a:r>
-                        <a:rPr sz="1200" b="0">
-                          <a:solidFill>
-                            <a:srgbClr val="333333"/>
-                          </a:solidFill>
-                        </a:rPr>
-                        <a:t>19 (1%)</a:t>
-                      </a:r>
-                    </a:p>
-                  </a:txBody>
-                  <a:tcPr marL="54864" marR="54864" marT="18288" marB="18288" anchor="ctr">
-                    <a:solidFill>
-                      <a:srgbClr val="FFFFFF"/>
-                    </a:solidFill>
-                  </a:tcPr>
-                </a:tc>
-                <a:tc>
-                  <a:txBody>
-                    <a:bodyPr wrap="square"/>
-                    <a:lstStyle/>
-                    <a:p>
-                      <a:pPr algn="ctr">
-                        <a:lnSpc>
-                          <a:spcPct val="100000"/>
-                        </a:lnSpc>
-                      </a:pPr>
-                      <a:r>
-                        <a:rPr sz="1200" b="0">
-                          <a:solidFill>
-                            <a:srgbClr val="333333"/>
-                          </a:solidFill>
-                        </a:rPr>
-                        <a:t>10.5%</a:t>
-                      </a:r>
-                    </a:p>
-                  </a:txBody>
-                  <a:tcPr marL="54864" marR="54864" marT="18288" marB="18288" anchor="ctr">
-                    <a:solidFill>
-                      <a:srgbClr val="FFFFFF"/>
-                    </a:solidFill>
-                  </a:tcPr>
-                </a:tc>
-                <a:tc>
-                  <a:txBody>
-                    <a:bodyPr wrap="square"/>
-                    <a:lstStyle/>
-                    <a:p>
-                      <a:pPr algn="ctr">
-                        <a:lnSpc>
-                          <a:spcPct val="100000"/>
-                        </a:lnSpc>
-                      </a:pPr>
-                      <a:r>
-                        <a:rPr sz="1200" b="0">
-                          <a:solidFill>
-                            <a:srgbClr val="333333"/>
-                          </a:solidFill>
-                        </a:rPr>
-                        <a:t>-409</a:t>
-                      </a:r>
-                    </a:p>
-                  </a:txBody>
-                  <a:tcPr marL="54864" marR="54864" marT="18288" marB="18288" anchor="ctr">
-                    <a:solidFill>
-                      <a:srgbClr val="FFFFFF"/>
-                    </a:solidFill>
-                  </a:tcPr>
-                </a:tc>
-                <a:tc>
-                  <a:txBody>
-                    <a:bodyPr wrap="square"/>
-                    <a:lstStyle/>
-                    <a:p>
-                      <a:pPr algn="ctr">
-                        <a:lnSpc>
-                          <a:spcPct val="100000"/>
-                        </a:lnSpc>
-                      </a:pPr>
-                      <a:r>
-                        <a:rPr sz="1200" b="0">
-                          <a:solidFill>
-                            <a:srgbClr val="333333"/>
-                          </a:solidFill>
-                        </a:rPr>
-                        <a:t>26.3%</a:t>
-                      </a:r>
-                    </a:p>
-                  </a:txBody>
-                  <a:tcPr marL="54864" marR="54864" marT="18288" marB="18288" anchor="ctr">
-                    <a:solidFill>
-                      <a:srgbClr val="FFFFFF"/>
-                    </a:solidFill>
-                  </a:tcPr>
-                </a:tc>
-                <a:tc>
-                  <a:txBody>
-                    <a:bodyPr wrap="square"/>
-                    <a:lstStyle/>
-                    <a:p>
-                      <a:pPr algn="ctr">
-                        <a:lnSpc>
-                          <a:spcPct val="100000"/>
-                        </a:lnSpc>
-                      </a:pPr>
-                      <a:r>
-                        <a:rPr sz="1200" b="0">
-                          <a:solidFill>
-                            <a:srgbClr val="333333"/>
-                          </a:solidFill>
-                        </a:rPr>
-                        <a:t>106.6</a:t>
-                      </a:r>
-                    </a:p>
-                  </a:txBody>
-                  <a:tcPr marL="54864" marR="54864" marT="18288" marB="18288" anchor="ctr">
-                    <a:solidFill>
-                      <a:srgbClr val="FFFFFF"/>
-                    </a:solidFill>
-                  </a:tcPr>
-                </a:tc>
-              </a:tr>
-              <a:tr h="475488">
-                <a:tc vMerge="1">
-                  <a:txBody>
-                    <a:bodyPr wrap="square"/>
-                    <a:lstStyle/>
-                    <a:p>
-                      <a:pPr algn="ctr">
-                        <a:lnSpc>
-                          <a:spcPct val="100000"/>
-                        </a:lnSpc>
-                      </a:pPr>
-                      <a:r>
-                        <a:rPr sz="1200" b="0">
-                          <a:solidFill>
-                            <a:srgbClr val="333333"/>
-                          </a:solidFill>
-                        </a:rPr>
-                        <a:t/>
-                      </a:r>
-                    </a:p>
-                  </a:txBody>
-                  <a:tcPr marL="54864" marR="54864" marT="18288" marB="18288" anchor="ctr">
-                    <a:solidFill>
-                      <a:srgbClr val="F2F2F2"/>
-                    </a:solidFill>
-                  </a:tcPr>
-                </a:tc>
-                <a:tc>
-                  <a:txBody>
-                    <a:bodyPr wrap="square"/>
-                    <a:lstStyle/>
-                    <a:p>
-                      <a:pPr algn="ctr">
-                        <a:lnSpc>
-                          <a:spcPct val="100000"/>
-                        </a:lnSpc>
-                      </a:pPr>
-                      <a:r>
-                        <a:rPr sz="1200" b="0">
-                          <a:solidFill>
-                            <a:srgbClr val="333333"/>
-                          </a:solidFill>
-                        </a:rPr>
-                        <a:t>test</a:t>
-                      </a:r>
-                    </a:p>
-                  </a:txBody>
-                  <a:tcPr marL="54864" marR="54864" marT="18288" marB="18288" anchor="ctr">
-                    <a:solidFill>
-                      <a:srgbClr val="F2F2F2"/>
-                    </a:solidFill>
-                  </a:tcPr>
-                </a:tc>
-                <a:tc>
-                  <a:txBody>
-                    <a:bodyPr wrap="square"/>
-                    <a:lstStyle/>
-                    <a:p>
-                      <a:pPr algn="ctr">
-                        <a:lnSpc>
-                          <a:spcPct val="100000"/>
-                        </a:lnSpc>
-                      </a:pPr>
-                      <a:r>
-                        <a:rPr sz="1200" b="0">
-                          <a:solidFill>
-                            <a:srgbClr val="333333"/>
-                          </a:solidFill>
-                        </a:rPr>
-                        <a:t>2 (0%)</a:t>
-                      </a:r>
-                    </a:p>
-                  </a:txBody>
-                  <a:tcPr marL="54864" marR="54864" marT="18288" marB="18288" anchor="ctr">
-                    <a:solidFill>
-                      <a:srgbClr val="F2F2F2"/>
-                    </a:solidFill>
-                  </a:tcPr>
-                </a:tc>
-                <a:tc>
-                  <a:txBody>
-                    <a:bodyPr wrap="square"/>
-                    <a:lstStyle/>
-                    <a:p>
-                      <a:pPr algn="ctr">
-                        <a:lnSpc>
-                          <a:spcPct val="100000"/>
-                        </a:lnSpc>
-                      </a:pPr>
-                      <a:r>
-                        <a:rPr sz="1200" b="0">
-                          <a:solidFill>
-                            <a:srgbClr val="333333"/>
-                          </a:solidFill>
-                        </a:rPr>
-                        <a:t>0%</a:t>
-                      </a:r>
-                    </a:p>
-                  </a:txBody>
-                  <a:tcPr marL="54864" marR="54864" marT="18288" marB="18288" anchor="ctr">
-                    <a:solidFill>
-                      <a:srgbClr val="F2F2F2"/>
-                    </a:solidFill>
-                  </a:tcPr>
-                </a:tc>
-                <a:tc>
-                  <a:txBody>
-                    <a:bodyPr wrap="square"/>
-                    <a:lstStyle/>
-                    <a:p>
-                      <a:pPr algn="ctr">
-                        <a:lnSpc>
-                          <a:spcPct val="100000"/>
-                        </a:lnSpc>
-                      </a:pPr>
-                      <a:r>
-                        <a:rPr sz="1200" b="0">
-                          <a:solidFill>
-                            <a:srgbClr val="333333"/>
-                          </a:solidFill>
-                        </a:rPr>
-                        <a:t>-64</a:t>
+                        <a:t>0</a:t>
                       </a:r>
                     </a:p>
                   </a:txBody>
@@ -8549,7 +8165,7 @@
                             <a:srgbClr val="333333"/>
                           </a:solidFill>
                         </a:rPr>
-                        <a:t>1950</a:t>
+                        <a:t>—</a:t>
                       </a:r>
                     </a:p>
                   </a:txBody>
@@ -8575,7 +8191,7 @@
                             <a:srgbClr val="333333"/>
                           </a:solidFill>
                         </a:rPr>
-                        <a:t>69.3%</a:t>
+                        <a:t>71.3%</a:t>
                       </a:r>
                     </a:p>
                   </a:txBody>
@@ -8601,7 +8217,7 @@
                             <a:srgbClr val="333333"/>
                           </a:solidFill>
                         </a:rPr>
-                        <a:t>+5074</a:t>
+                        <a:t>+6884</a:t>
                       </a:r>
                     </a:p>
                   </a:txBody>
@@ -8733,7 +8349,7 @@
                             <a:srgbClr val="333333"/>
                           </a:solidFill>
                         </a:rPr>
-                        <a:t>960</a:t>
+                        <a:t>—</a:t>
                       </a:r>
                     </a:p>
                   </a:txBody>
@@ -8759,7 +8375,7 @@
                             <a:srgbClr val="333333"/>
                           </a:solidFill>
                         </a:rPr>
-                        <a:t>67.8%</a:t>
+                        <a:t>68.8%</a:t>
                       </a:r>
                     </a:p>
                   </a:txBody>
@@ -8785,7 +8401,7 @@
                             <a:srgbClr val="333333"/>
                           </a:solidFill>
                         </a:rPr>
-                        <a:t>+1744</a:t>
+                        <a:t>+2243</a:t>
                       </a:r>
                     </a:p>
                   </a:txBody>
@@ -8888,7 +8504,7 @@
                   <a:srgbClr val="1F4E79"/>
                 </a:solidFill>
               </a:rPr>
-              <a:t>•  SNLNDRO：价差系统性偏正（约 2/3 时间 DA&gt;RTPD），预测正价差命中 68–70%，幅度小（±10）风险可控 → 稳定盈利</a:t>
+              <a:t>•  SNLNDRO：价差系统性偏正（test 实际正价差 62.6%），预测正价差命中 68.8%，幅度小（±8）风险可控 → 稳定盈利</a:t>
             </a:r>
           </a:p>
           <a:p>
@@ -8906,7 +8522,7 @@
                   <a:srgbClr val="333333"/>
                 </a:solidFill>
               </a:rPr>
-              <a:t>•  CONTROLX：实际正价差仅占 26–34%，模型“预测正价差”信号弱（命中 10%），单边规则下几乎不触发交易 → 主动避开大幅度节点</a:t>
+              <a:t>•  CONTROLX：实际正价差仅占 33.9%、幅度高达 ±214，CatBoost 几乎不给出“卖”信号（test 0 笔交易）→ 主动避开大幅度节点</a:t>
             </a:r>
           </a:p>
           <a:p>
@@ -9019,7 +8635,7 @@
                   <a:srgbClr val="1F4E79"/>
                 </a:solidFill>
               </a:rPr>
-              <a:t>影响因子：DA 价滞后结构主导方向信号</a:t>
+              <a:t>影响因子：DA 价滞后 + 价差波动主导</a:t>
             </a:r>
           </a:p>
         </p:txBody>
@@ -9152,7 +8768,7 @@
         <p:spPr>
           <a:xfrm>
             <a:off x="822960" y="1371600"/>
-            <a:ext cx="9699077376000" cy="3353568818661"/>
+            <a:ext cx="9699077376000" cy="3176323192684"/>
           </a:xfrm>
           <a:prstGeom prst="rect">
             <a:avLst/>
@@ -9195,7 +8811,7 @@
                   <a:srgbClr val="1F4E79"/>
                 </a:solidFill>
               </a:rPr>
-              <a:t>•  历史价格滞后共占 72.8%（其中 DA 价滞后约 60%）—— DA 价是 T-1 已确定的撮合价，对次日价差方向最具预示力</a:t>
+              <a:t>•  历史滞后共 44.4%（da_lag2 15.8% + da_lag1 5.5% 领衔）—— 日前撮合价对次日方向最具预示力</a:t>
             </a:r>
           </a:p>
           <a:p>
@@ -9213,7 +8829,7 @@
                   <a:srgbClr val="333333"/>
                 </a:solidFill>
               </a:rPr>
-              <a:t>•  其次为 D+1 负荷与天气预报（18.3%）、日历（8.2%）、滚动统计（6.9%）、节点（0.7%）</a:t>
+              <a:t>•  波动统计升至第二（24.1%：spread_std14 13.1%、spread_std7 7.8%）；未来预报 22.9%、日历 9.7%、节点 6.9%</a:t>
             </a:r>
           </a:p>
         </p:txBody>
@@ -9441,7 +9057,7 @@
         <p:spPr>
           <a:xfrm>
             <a:off x="822960" y="1371600"/>
-            <a:ext cx="9699077376000" cy="3452076473013"/>
+            <a:ext cx="9699077376000" cy="3417770122971"/>
           </a:xfrm>
           <a:prstGeom prst="rect">
             <a:avLst/>
@@ -9484,7 +9100,7 @@
                   <a:srgbClr val="1F4E79"/>
                 </a:solidFill>
               </a:rPr>
-              <a:t>•  单边策略 +1744 vs 全交易 -129,655：规避了约 13 万美元的大亏（hold 单笔最多避开 -2,251）</a:t>
+              <a:t>•  单边策略 +2243 vs 全交易 -128,259：规避了约 12.8 万美元的大亏</a:t>
             </a:r>
           </a:p>
           <a:p>
@@ -9502,7 +9118,7 @@
                   <a:srgbClr val="333333"/>
                 </a:solidFill>
               </a:rPr>
-              <a:t>•  反向 +129,655 为“全交易取负”的镜像上界，非可执行策略；不交易 0 为下限</a:t>
+              <a:t>•  反向 +128,259 为“全交易取负”的镜像上界，非可执行策略；不交易 0 为下限</a:t>
             </a:r>
           </a:p>
           <a:p>
@@ -9615,7 +9231,7 @@
                   <a:srgbClr val="1F4E79"/>
                 </a:solidFill>
               </a:rPr>
-              <a:t>套利收益曲线：test 累计 +1744</a:t>
+              <a:t>套利收益曲线：test 累计 +2243</a:t>
             </a:r>
           </a:p>
         </p:txBody>
@@ -9791,7 +9407,7 @@
                   <a:srgbClr val="1F4E79"/>
                 </a:solidFill>
               </a:rPr>
-              <a:t>•  test（2026-06 ~ 08，65 天）模拟套利累计 +1744，日均约 +27</a:t>
+              <a:t>•  test（2026-06 ~ 08，65 天）模拟套利累计 +2243，日均约 +35</a:t>
             </a:r>
           </a:p>
           <a:p>
@@ -9809,7 +9425,7 @@
                   <a:srgbClr val="333333"/>
                 </a:solidFill>
               </a:rPr>
-              <a:t>•  最大单笔亏损 -162（单边规则 + std7 风控下亏损可控）</a:t>
+              <a:t>•  最大单笔亏损 -171（单边规则 + std7 风控下亏损可控）</a:t>
             </a:r>
           </a:p>
           <a:p>
@@ -9827,7 +9443,7 @@
                   <a:srgbClr val="333333"/>
                 </a:solidFill>
               </a:rPr>
-              <a:t>•  val 同时段为正：+5074（2026 H1）—— 双时段验证，避免只在测试集上调参</a:t>
+              <a:t>•  val 同时段为正：+6884（2026 H1）—— 双时段验证，避免只在测试集上调参</a:t>
             </a:r>
           </a:p>
         </p:txBody>

</xml_diff>